<commit_message>
Slide 1: add Team Knox and members, align the example with the demo video
The video narrates the correction as Paris -> Delhi; the slide said Berlin.
Updated the quote and both flow steps on slide 1 so the deck matches what is
spoken. Team name and members added to the title slide.
</commit_message>
<xml_diff>
--- a/docs/Interruptible-Voice-Agents.pptx
+++ b/docs/Interruptible-Voice-Agents.pptx
@@ -1663,7 +1663,7 @@
               </a:defRPr>
             </a:pPr>
             <a:r>
-              <a:t>no wait, make that Berlin.”</a:t>
+              <a:t>no wait, make that Delhi.”</a:t>
             </a:r>
           </a:p>
         </p:txBody>
@@ -2202,7 +2202,7 @@
             <a:p>
               <a:pPr/>
               <a:r>
-                <a:t>User corrects to Berlin</a:t>
+                <a:t>User corrects to Delhi</a:t>
               </a:r>
             </a:p>
           </p:txBody>
@@ -2348,7 +2348,7 @@
             <a:p>
               <a:pPr/>
               <a:r>
-                <a:t>Berlin is now the correct intent</a:t>
+                <a:t>Delhi is now the correct intent</a:t>
               </a:r>
             </a:p>
           </p:txBody>
@@ -2708,6 +2708,51 @@
             <a:pPr/>
             <a:r>
               <a:t>Interruptible Voice Agents: When Timing Matters</a:t>
+            </a:r>
+          </a:p>
+        </p:txBody>
+      </p:sp>
+      <p:sp>
+        <p:nvSpPr>
+          <p:cNvPr id="59" name="TextBox 58"/>
+          <p:cNvSpPr txBox="1"/>
+          <p:nvPr/>
+        </p:nvSpPr>
+        <p:spPr>
+          <a:xfrm>
+            <a:off x="5349240" y="155448"/>
+            <a:ext cx="3566160" cy="420624"/>
+          </a:xfrm>
+          <a:prstGeom prst="rect">
+            <a:avLst/>
+          </a:prstGeom>
+          <a:noFill/>
+        </p:spPr>
+        <p:txBody>
+          <a:bodyPr wrap="square" lIns="0" rIns="0" tIns="0" bIns="0">
+            <a:spAutoFit/>
+          </a:bodyPr>
+          <a:lstStyle/>
+          <a:p>
+            <a:pPr algn="r"/>
+            <a:r>
+              <a:rPr sz="1200" b="1">
+                <a:solidFill>
+                  <a:srgbClr val="E6EDF3"/>
+                </a:solidFill>
+              </a:rPr>
+              <a:t>Team Knox</a:t>
+            </a:r>
+          </a:p>
+          <a:p>
+            <a:pPr algn="r"/>
+            <a:r>
+              <a:rPr sz="850">
+                <a:solidFill>
+                  <a:srgbClr val="8B949E"/>
+                </a:solidFill>
+              </a:rPr>
+              <a:t>Aiyana Sehgal  ·  Srinjoyee Acharyya  ·  Simran Das</a:t>
             </a:r>
           </a:p>
         </p:txBody>

</xml_diff>

<commit_message>
Slide 1: match the demo video's Delhi-Goa to Jaipur example
The video narrates "book me a flight from Delhi to Goa on November 5th... no
wait, let's do a road trip to Jaipur on the 6th instead". Slide 1 used a
Paris/Berlin example, so the quote and all six flow steps are updated to the
spoken one: the stale call is the Delhi-to-Goa flight search, and the corrected
intent is the Jaipur road trip.
</commit_message>
<xml_diff>
--- a/docs/Interruptible-Voice-Agents.pptx
+++ b/docs/Interruptible-Voice-Agents.pptx
@@ -1651,7 +1651,8 @@
               </a:defRPr>
             </a:pPr>
             <a:r>
-              <a:t>“Book a flight to Paris on the tenth…</a:t>
+              <a:rPr sz="1600"/>
+              <a:t>“Book me a flight from Delhi to Goa on November 5th…</a:t>
             </a:r>
           </a:p>
           <a:p>
@@ -1663,7 +1664,8 @@
               </a:defRPr>
             </a:pPr>
             <a:r>
-              <a:t>no wait, make that Delhi.”</a:t>
+              <a:rPr sz="1600"/>
+              <a:t>no wait — let’s do a road trip to Jaipur on the 6th instead.”</a:t>
             </a:r>
           </a:p>
         </p:txBody>
@@ -1764,7 +1766,7 @@
             <a:p>
               <a:pPr/>
               <a:r>
-                <a:t>User says Paris</a:t>
+                <a:t>User says Delhi → Goa</a:t>
               </a:r>
             </a:p>
           </p:txBody>
@@ -1910,7 +1912,7 @@
             <a:p>
               <a:pPr/>
               <a:r>
-                <a:t>LLM proposes Paris</a:t>
+                <a:t>LLM proposes flight search</a:t>
               </a:r>
             </a:p>
           </p:txBody>
@@ -2056,7 +2058,7 @@
             <a:p>
               <a:pPr/>
               <a:r>
-                <a:t>Paris tool call starts</a:t>
+                <a:t>Flight search call starts</a:t>
               </a:r>
             </a:p>
           </p:txBody>
@@ -2202,7 +2204,7 @@
             <a:p>
               <a:pPr/>
               <a:r>
-                <a:t>User corrects to Delhi</a:t>
+                <a:t>User corrects to Jaipur</a:t>
               </a:r>
             </a:p>
           </p:txBody>
@@ -2348,7 +2350,7 @@
             <a:p>
               <a:pPr/>
               <a:r>
-                <a:t>Delhi is now the correct intent</a:t>
+                <a:t>Jaipur road trip is the intent</a:t>
               </a:r>
             </a:p>
           </p:txBody>
@@ -2501,7 +2503,7 @@
                 <a:t>✕ </a:t>
               </a:r>
               <a:r>
-                <a:t>But the stale Paris call already happened</a:t>
+                <a:t>But the stale flight call already happened</a:t>
               </a:r>
             </a:p>
           </p:txBody>

</xml_diff>